<commit_message>
added Session PDF file
</commit_message>
<xml_diff>
--- a/Session PPT.pptx
+++ b/Session PPT.pptx
@@ -336,7 +336,7 @@
             <a:fld id="{1D8BD707-D9CF-40AE-B4C6-C98DA3205C09}" type="datetimeFigureOut">
               <a:rPr lang="en-US" smtClean="0"/>
               <a:pPr/>
-              <a:t>9/24/2025</a:t>
+              <a:t>4/16/2026</a:t>
             </a:fld>
             <a:endParaRPr lang="en-US"/>
           </a:p>
@@ -501,7 +501,7 @@
             <a:fld id="{1D8BD707-D9CF-40AE-B4C6-C98DA3205C09}" type="datetimeFigureOut">
               <a:rPr lang="en-US" smtClean="0"/>
               <a:pPr/>
-              <a:t>9/24/2025</a:t>
+              <a:t>4/16/2026</a:t>
             </a:fld>
             <a:endParaRPr lang="en-US"/>
           </a:p>
@@ -676,7 +676,7 @@
             <a:fld id="{1D8BD707-D9CF-40AE-B4C6-C98DA3205C09}" type="datetimeFigureOut">
               <a:rPr lang="en-US" smtClean="0"/>
               <a:pPr/>
-              <a:t>9/24/2025</a:t>
+              <a:t>4/16/2026</a:t>
             </a:fld>
             <a:endParaRPr lang="en-US"/>
           </a:p>
@@ -841,7 +841,7 @@
             <a:fld id="{1D8BD707-D9CF-40AE-B4C6-C98DA3205C09}" type="datetimeFigureOut">
               <a:rPr lang="en-US" smtClean="0"/>
               <a:pPr/>
-              <a:t>9/24/2025</a:t>
+              <a:t>4/16/2026</a:t>
             </a:fld>
             <a:endParaRPr lang="en-US"/>
           </a:p>
@@ -1083,7 +1083,7 @@
             <a:fld id="{1D8BD707-D9CF-40AE-B4C6-C98DA3205C09}" type="datetimeFigureOut">
               <a:rPr lang="en-US" smtClean="0"/>
               <a:pPr/>
-              <a:t>9/24/2025</a:t>
+              <a:t>4/16/2026</a:t>
             </a:fld>
             <a:endParaRPr lang="en-US"/>
           </a:p>
@@ -1365,7 +1365,7 @@
             <a:fld id="{1D8BD707-D9CF-40AE-B4C6-C98DA3205C09}" type="datetimeFigureOut">
               <a:rPr lang="en-US" smtClean="0"/>
               <a:pPr/>
-              <a:t>9/24/2025</a:t>
+              <a:t>4/16/2026</a:t>
             </a:fld>
             <a:endParaRPr lang="en-US"/>
           </a:p>
@@ -1781,7 +1781,7 @@
             <a:fld id="{1D8BD707-D9CF-40AE-B4C6-C98DA3205C09}" type="datetimeFigureOut">
               <a:rPr lang="en-US" smtClean="0"/>
               <a:pPr/>
-              <a:t>9/24/2025</a:t>
+              <a:t>4/16/2026</a:t>
             </a:fld>
             <a:endParaRPr lang="en-US"/>
           </a:p>
@@ -1895,7 +1895,7 @@
             <a:fld id="{1D8BD707-D9CF-40AE-B4C6-C98DA3205C09}" type="datetimeFigureOut">
               <a:rPr lang="en-US" smtClean="0"/>
               <a:pPr/>
-              <a:t>9/24/2025</a:t>
+              <a:t>4/16/2026</a:t>
             </a:fld>
             <a:endParaRPr lang="en-US"/>
           </a:p>
@@ -1987,7 +1987,7 @@
             <a:fld id="{1D8BD707-D9CF-40AE-B4C6-C98DA3205C09}" type="datetimeFigureOut">
               <a:rPr lang="en-US" smtClean="0"/>
               <a:pPr/>
-              <a:t>9/24/2025</a:t>
+              <a:t>4/16/2026</a:t>
             </a:fld>
             <a:endParaRPr lang="en-US"/>
           </a:p>
@@ -2259,7 +2259,7 @@
             <a:fld id="{1D8BD707-D9CF-40AE-B4C6-C98DA3205C09}" type="datetimeFigureOut">
               <a:rPr lang="en-US" smtClean="0"/>
               <a:pPr/>
-              <a:t>9/24/2025</a:t>
+              <a:t>4/16/2026</a:t>
             </a:fld>
             <a:endParaRPr lang="en-US"/>
           </a:p>
@@ -2508,7 +2508,7 @@
             <a:fld id="{1D8BD707-D9CF-40AE-B4C6-C98DA3205C09}" type="datetimeFigureOut">
               <a:rPr lang="en-US" smtClean="0"/>
               <a:pPr/>
-              <a:t>9/24/2025</a:t>
+              <a:t>4/16/2026</a:t>
             </a:fld>
             <a:endParaRPr lang="en-US"/>
           </a:p>
@@ -2716,7 +2716,7 @@
             <a:fld id="{1D8BD707-D9CF-40AE-B4C6-C98DA3205C09}" type="datetimeFigureOut">
               <a:rPr lang="en-US" smtClean="0"/>
               <a:pPr/>
-              <a:t>9/24/2025</a:t>
+              <a:t>4/16/2026</a:t>
             </a:fld>
             <a:endParaRPr lang="en-US"/>
           </a:p>

</xml_diff>